<commit_message>
checkpoint: halitosis suppliers — replace Hanyutang/Llrn with Per Os Bio + BLIS
Per user feedback: previous picks were Alibaba aggregator search results,
not specific white-label lozenge CDMOs with correct halitosis ingredients.

New halitosis slate:
- Pharmaloz Manufacturing (US, PA) — 84/100, lead pick, custom zinc + xylitol
- Per Os Biosciences (US, MD) — 75/100, FDA cGMP compressed lozenge CDMO
- BLIS Technologies (NZ) — 82/100, root-cause S. salivarius K12 finished-goods PL

All three are verified named contract manufacturers with halitosis-relevant
ingredient capability, live URLs, and direct private-label programs.

Co-Authored-By: Claude Opus 4.7 <noreply@anthropic.com>
</commit_message>
<xml_diff>
--- a/business documents/Aplomb_Supplier_Shortlist_v1.pptx
+++ b/business documents/Aplomb_Supplier_Shortlist_v1.pptx
@@ -300,7 +300,7 @@
           <a:p>
             <a:fld id="{5BCAD085-E8A6-8845-BD4E-CB4CCA059FC4}" type="datetimeFigureOut">
               <a:rPr lang="en-US"/>
-              <a:t>5/3/26</a:t>
+              <a:t>5/4/26</a:t>
             </a:fld>
             <a:endParaRPr lang="en-US"/>
           </a:p>
@@ -470,7 +470,7 @@
           <a:p>
             <a:fld id="{5BCAD085-E8A6-8845-BD4E-CB4CCA059FC4}" type="datetimeFigureOut">
               <a:rPr lang="en-US"/>
-              <a:t>5/3/26</a:t>
+              <a:t>5/4/26</a:t>
             </a:fld>
             <a:endParaRPr lang="en-US"/>
           </a:p>
@@ -650,7 +650,7 @@
           <a:p>
             <a:fld id="{5BCAD085-E8A6-8845-BD4E-CB4CCA059FC4}" type="datetimeFigureOut">
               <a:rPr lang="en-US"/>
-              <a:t>5/3/26</a:t>
+              <a:t>5/4/26</a:t>
             </a:fld>
             <a:endParaRPr lang="en-US"/>
           </a:p>
@@ -820,7 +820,7 @@
           <a:p>
             <a:fld id="{5BCAD085-E8A6-8845-BD4E-CB4CCA059FC4}" type="datetimeFigureOut">
               <a:rPr lang="en-US"/>
-              <a:t>5/3/26</a:t>
+              <a:t>5/4/26</a:t>
             </a:fld>
             <a:endParaRPr lang="en-US"/>
           </a:p>
@@ -1066,7 +1066,7 @@
           <a:p>
             <a:fld id="{5BCAD085-E8A6-8845-BD4E-CB4CCA059FC4}" type="datetimeFigureOut">
               <a:rPr lang="en-US"/>
-              <a:t>5/3/26</a:t>
+              <a:t>5/4/26</a:t>
             </a:fld>
             <a:endParaRPr lang="en-US"/>
           </a:p>
@@ -1354,7 +1354,7 @@
           <a:p>
             <a:fld id="{5BCAD085-E8A6-8845-BD4E-CB4CCA059FC4}" type="datetimeFigureOut">
               <a:rPr lang="en-US"/>
-              <a:t>5/3/26</a:t>
+              <a:t>5/4/26</a:t>
             </a:fld>
             <a:endParaRPr lang="en-US"/>
           </a:p>
@@ -1776,7 +1776,7 @@
           <a:p>
             <a:fld id="{5BCAD085-E8A6-8845-BD4E-CB4CCA059FC4}" type="datetimeFigureOut">
               <a:rPr lang="en-US"/>
-              <a:t>5/3/26</a:t>
+              <a:t>5/4/26</a:t>
             </a:fld>
             <a:endParaRPr lang="en-US"/>
           </a:p>
@@ -1894,7 +1894,7 @@
           <a:p>
             <a:fld id="{5BCAD085-E8A6-8845-BD4E-CB4CCA059FC4}" type="datetimeFigureOut">
               <a:rPr lang="en-US"/>
-              <a:t>5/3/26</a:t>
+              <a:t>5/4/26</a:t>
             </a:fld>
             <a:endParaRPr lang="en-US"/>
           </a:p>
@@ -1989,7 +1989,7 @@
           <a:p>
             <a:fld id="{5BCAD085-E8A6-8845-BD4E-CB4CCA059FC4}" type="datetimeFigureOut">
               <a:rPr lang="en-US"/>
-              <a:t>5/3/26</a:t>
+              <a:t>5/4/26</a:t>
             </a:fld>
             <a:endParaRPr lang="en-US"/>
           </a:p>
@@ -2266,7 +2266,7 @@
           <a:p>
             <a:fld id="{5BCAD085-E8A6-8845-BD4E-CB4CCA059FC4}" type="datetimeFigureOut">
               <a:rPr lang="en-US"/>
-              <a:t>5/3/26</a:t>
+              <a:t>5/4/26</a:t>
             </a:fld>
             <a:endParaRPr lang="en-US"/>
           </a:p>
@@ -2519,7 +2519,7 @@
           <a:p>
             <a:fld id="{5BCAD085-E8A6-8845-BD4E-CB4CCA059FC4}" type="datetimeFigureOut">
               <a:rPr lang="en-US"/>
-              <a:t>5/3/26</a:t>
+              <a:t>5/4/26</a:t>
             </a:fld>
             <a:endParaRPr lang="en-US"/>
           </a:p>
@@ -2732,7 +2732,7 @@
           <a:p>
             <a:fld id="{5BCAD085-E8A6-8845-BD4E-CB4CCA059FC4}" type="datetimeFigureOut">
               <a:rPr lang="en-US"/>
-              <a:t>5/3/26</a:t>
+              <a:t>5/4/26</a:t>
             </a:fld>
             <a:endParaRPr lang="en-US"/>
           </a:p>
@@ -3618,7 +3618,7 @@
                 </a:solidFill>
                 <a:latin typeface="IBM Plex Sans"/>
               </a:rPr>
-              <a:t>For Zachary Poll · Prepared 2026-05-03 · Confidential</a:t>
+              <a:t>For Zachary Poll · Prepared 2026-05-04 · Confidential</a:t>
             </a:r>
           </a:p>
         </p:txBody>
@@ -8063,7 +8063,7 @@
                 </a:solidFill>
                 <a:latin typeface="IBM Plex Sans"/>
               </a:rPr>
-              <a:t>  ·  score 78/100  ·  MOQ 100  ·  total $250</a:t>
+              <a:t>  ·  score 84/100  ·  MOQ 100  ·  total $250</a:t>
             </a:r>
           </a:p>
           <a:p>
@@ -13745,13 +13745,13 @@
                           </a:solidFill>
                           <a:latin typeface="IBM Plex Sans"/>
                         </a:rPr>
-                        <a:t>78</a:t>
+                        <a:t>84</a:t>
                       </a:r>
                     </a:p>
                   </a:txBody>
                   <a:tcPr>
                     <a:solidFill>
-                      <a:srgbClr val="F7F1E6"/>
+                      <a:srgbClr val="E6C99C"/>
                     </a:solidFill>
                   </a:tcPr>
                 </a:tc>
@@ -13801,7 +13801,7 @@
                           </a:solidFill>
                           <a:latin typeface="IBM Plex Sans"/>
                         </a:rPr>
-                        <a:t>Hanyutang (Alibaba)</a:t>
+                        <a:t>Per Os Biosciences</a:t>
                       </a:r>
                     </a:p>
                   </a:txBody>
@@ -13829,7 +13829,7 @@
                           <a:latin typeface="IBM Plex Sans"/>
                           <a:hlinkClick r:id="rId4"/>
                         </a:rPr>
-                        <a:t>alibaba.com/showroom/oral-…</a:t>
+                        <a:t>peros-bio.com</a:t>
                       </a:r>
                     </a:p>
                   </a:txBody>
@@ -13856,7 +13856,7 @@
                           </a:solidFill>
                           <a:latin typeface="IBM Plex Sans"/>
                         </a:rPr>
-                        <a:t>OEM zinc lozenge / xylitol mint, private-label packaging</a:t>
+                        <a:t>Compressed lozenge / chewable tablet CDMO — direct-compression zinc + xylitol; FDA cGMP, Kosher (Star-K)</a:t>
                       </a:r>
                     </a:p>
                   </a:txBody>
@@ -13884,7 +13884,7 @@
                           <a:latin typeface="IBM Plex Sans"/>
                           <a:hlinkClick r:id="rId5"/>
                         </a:rPr>
-                        <a:t>Oral Care OEM Listings</a:t>
+                        <a:t>Contract Manufacturing — Lozenges</a:t>
                       </a:r>
                     </a:p>
                   </a:txBody>
@@ -13938,7 +13938,7 @@
                           </a:solidFill>
                           <a:latin typeface="IBM Plex Sans"/>
                         </a:rPr>
-                        <a:t>$1.50</a:t>
+                        <a:t>$2.40</a:t>
                       </a:r>
                     </a:p>
                   </a:txBody>
@@ -13965,7 +13965,7 @@
                           </a:solidFill>
                           <a:latin typeface="IBM Plex Sans"/>
                         </a:rPr>
-                        <a:t>$150</a:t>
+                        <a:t>$240</a:t>
                       </a:r>
                     </a:p>
                   </a:txBody>
@@ -13992,7 +13992,7 @@
                           </a:solidFill>
                           <a:latin typeface="IBM Plex Sans"/>
                         </a:rPr>
-                        <a:t>65</a:t>
+                        <a:t>75</a:t>
                       </a:r>
                     </a:p>
                   </a:txBody>
@@ -14019,7 +14019,7 @@
                           </a:solidFill>
                           <a:latin typeface="IBM Plex Sans"/>
                         </a:rPr>
-                        <a:t>China — accepts MOQ 100 at slightly higher unit price. Verify specific seller via Alibaba; multiple Hanyutang-branded sellers exist in this category.</a:t>
+                        <a:t>Maryland-based; 28K sqft allergen-free facility. Custom dental &amp; dietary-supplement lozenge formulation in-house. RFQ pilot run; MOQ negotiable for niche launches.</a:t>
                       </a:r>
                     </a:p>
                   </a:txBody>
@@ -14048,7 +14048,7 @@
                           </a:solidFill>
                           <a:latin typeface="IBM Plex Sans"/>
                         </a:rPr>
-                        <a:t>Llrn Personal Care</a:t>
+                        <a:t>BLIS Technologies</a:t>
                       </a:r>
                     </a:p>
                   </a:txBody>
@@ -14076,7 +14076,7 @@
                           <a:latin typeface="IBM Plex Sans"/>
                           <a:hlinkClick r:id="rId6"/>
                         </a:rPr>
-                        <a:t>alibaba.com/supplier/breat…</a:t>
+                        <a:t>blis.co.nz</a:t>
                       </a:r>
                     </a:p>
                   </a:txBody>
@@ -14103,7 +14103,7 @@
                           </a:solidFill>
                           <a:latin typeface="IBM Plex Sans"/>
                         </a:rPr>
-                        <a:t>Breath spray (xylitol + mint) + zinc lozenge OEM; private label</a:t>
+                        <a:t>Private-label S. salivarius K12 lozenge — root-cause oral probiotic with halitosis clinical evidence</a:t>
                       </a:r>
                     </a:p>
                   </a:txBody>
@@ -14131,7 +14131,7 @@
                           <a:latin typeface="IBM Plex Sans"/>
                           <a:hlinkClick r:id="rId7"/>
                         </a:rPr>
-                        <a:t>Llrn Storefront — Oral Care</a:t>
+                        <a:t>K12 FreshBreath Lozenge (Private Label)</a:t>
                       </a:r>
                     </a:p>
                   </a:txBody>
@@ -14185,7 +14185,7 @@
                           </a:solidFill>
                           <a:latin typeface="IBM Plex Sans"/>
                         </a:rPr>
-                        <a:t>$1.00</a:t>
+                        <a:t>$2.00</a:t>
                       </a:r>
                     </a:p>
                   </a:txBody>
@@ -14212,7 +14212,7 @@
                           </a:solidFill>
                           <a:latin typeface="IBM Plex Sans"/>
                         </a:rPr>
-                        <a:t>$100</a:t>
+                        <a:t>$200</a:t>
                       </a:r>
                     </a:p>
                   </a:txBody>
@@ -14239,13 +14239,13 @@
                           </a:solidFill>
                           <a:latin typeface="IBM Plex Sans"/>
                         </a:rPr>
-                        <a:t>60</a:t>
+                        <a:t>82</a:t>
                       </a:r>
                     </a:p>
                   </a:txBody>
                   <a:tcPr>
                     <a:solidFill>
-                      <a:srgbClr val="F7F1E6"/>
+                      <a:srgbClr val="E6C99C"/>
                     </a:solidFill>
                   </a:tcPr>
                 </a:tc>
@@ -14266,7 +14266,7 @@
                           </a:solidFill>
                           <a:latin typeface="IBM Plex Sans"/>
                         </a:rPr>
-                        <a:t>Shenzhen-based oral-care OEM. Lowest cash outlay. Format leans spray/mint; lozenge available on custom run. Verify zinc/xylitol spec sheet before order.</a:t>
+                        <a:t>NZ; only finished-goods private-label K12 program. 1.25B CFU peppermint lozenge, 40-ct blister pack. RFQ MOQ; positioned as the root-cause SKU in our 3-supplier slate.</a:t>
                       </a:r>
                     </a:p>
                   </a:txBody>
@@ -14378,7 +14378,7 @@
                 </a:solidFill>
                 <a:latin typeface="IBM Plex Sans"/>
               </a:rPr>
-              <a:t> · score 78/100 · MOQ 100 · $2.50/unit · total $250</a:t>
+              <a:t> · score 84/100 · MOQ 100 · $2.50/unit · total $250</a:t>
             </a:r>
           </a:p>
         </p:txBody>

</xml_diff>